<commit_message>
created logo for project
</commit_message>
<xml_diff>
--- a/Documentation/Fyp Proposal/ContracthubPK Proposal Defence.pptx
+++ b/Documentation/Fyp Proposal/ContracthubPK Proposal Defence.pptx
@@ -2392,7 +2392,7 @@
               <a:pPr>
                 <a:defRPr/>
               </a:pPr>
-              <a:t>1/10/2026</a:t>
+              <a:t>2/3/2026</a:t>
             </a:fld>
             <a:endParaRPr lang="en-US" altLang="en-US"/>
           </a:p>
@@ -2646,7 +2646,7 @@
               <a:pPr>
                 <a:defRPr/>
               </a:pPr>
-              <a:t>1/10/2026</a:t>
+              <a:t>2/3/2026</a:t>
             </a:fld>
             <a:endParaRPr lang="en-US" altLang="en-US"/>
           </a:p>
@@ -2855,7 +2855,7 @@
               <a:pPr>
                 <a:defRPr/>
               </a:pPr>
-              <a:t>1/10/2026</a:t>
+              <a:t>2/3/2026</a:t>
             </a:fld>
             <a:endParaRPr lang="en-US" altLang="en-US"/>
           </a:p>
@@ -3054,7 +3054,7 @@
               <a:pPr>
                 <a:defRPr/>
               </a:pPr>
-              <a:t>1/10/2026</a:t>
+              <a:t>2/3/2026</a:t>
             </a:fld>
             <a:endParaRPr lang="en-US" altLang="en-US"/>
           </a:p>
@@ -3276,7 +3276,7 @@
               <a:pPr>
                 <a:defRPr/>
               </a:pPr>
-              <a:t>1/10/2026</a:t>
+              <a:t>2/3/2026</a:t>
             </a:fld>
             <a:endParaRPr lang="en-US" altLang="en-US"/>
           </a:p>
@@ -3592,7 +3592,7 @@
               <a:pPr>
                 <a:defRPr/>
               </a:pPr>
-              <a:t>1/10/2026</a:t>
+              <a:t>2/3/2026</a:t>
             </a:fld>
             <a:endParaRPr lang="en-US" altLang="en-US"/>
           </a:p>
@@ -4047,7 +4047,7 @@
               <a:pPr>
                 <a:defRPr/>
               </a:pPr>
-              <a:t>1/10/2026</a:t>
+              <a:t>2/3/2026</a:t>
             </a:fld>
             <a:endParaRPr lang="en-US" altLang="en-US"/>
           </a:p>
@@ -4195,7 +4195,7 @@
               <a:pPr>
                 <a:defRPr/>
               </a:pPr>
-              <a:t>1/10/2026</a:t>
+              <a:t>2/3/2026</a:t>
             </a:fld>
             <a:endParaRPr lang="en-US" altLang="en-US"/>
           </a:p>
@@ -4321,7 +4321,7 @@
               <a:pPr>
                 <a:defRPr/>
               </a:pPr>
-              <a:t>1/10/2026</a:t>
+              <a:t>2/3/2026</a:t>
             </a:fld>
             <a:endParaRPr lang="en-US" altLang="en-US"/>
           </a:p>
@@ -4627,7 +4627,7 @@
               <a:pPr>
                 <a:defRPr/>
               </a:pPr>
-              <a:t>1/10/2026</a:t>
+              <a:t>2/3/2026</a:t>
             </a:fld>
             <a:endParaRPr lang="en-US" altLang="en-US"/>
           </a:p>
@@ -4911,7 +4911,7 @@
               <a:pPr>
                 <a:defRPr/>
               </a:pPr>
-              <a:t>1/10/2026</a:t>
+              <a:t>2/3/2026</a:t>
             </a:fld>
             <a:endParaRPr lang="en-US" altLang="en-US"/>
           </a:p>
@@ -5237,7 +5237,7 @@
               <a:pPr>
                 <a:defRPr/>
               </a:pPr>
-              <a:t>1/10/2026</a:t>
+              <a:t>2/3/2026</a:t>
             </a:fld>
             <a:endParaRPr lang="en-US" altLang="en-US"/>
           </a:p>
@@ -7128,7 +7128,7 @@
         <p:spPr>
           <a:xfrm>
             <a:off x="2300068" y="5039585"/>
-            <a:ext cx="1941557" cy="369332"/>
+            <a:ext cx="2069797" cy="369332"/>
           </a:xfrm>
           <a:prstGeom prst="rect">
             <a:avLst/>
@@ -7143,7 +7143,7 @@
           <a:p>
             <a:r>
               <a:rPr lang="en-US" dirty="0"/>
-              <a:t>Dr Mehwish Ilyas</a:t>
+              <a:t>Dr Mahwish Ilayas</a:t>
             </a:r>
             <a:endParaRPr lang="en-PK" dirty="0"/>
           </a:p>
@@ -7652,7 +7652,7 @@
             <a:fld id="{3CFAEDAC-8F83-4A0E-9275-3AC03E30CD5E}" type="datetime1">
               <a:rPr lang="en-US" altLang="en-US"/>
               <a:pPr/>
-              <a:t>1/10/2026</a:t>
+              <a:t>2/3/2026</a:t>
             </a:fld>
             <a:endParaRPr lang="en-US" altLang="en-US"/>
           </a:p>
@@ -7972,7 +7972,7 @@
             <a:fld id="{616B4EEC-7D92-43E3-9DF5-5E76824E7D85}" type="datetime1">
               <a:rPr lang="en-US" altLang="en-US"/>
               <a:pPr/>
-              <a:t>1/10/2026</a:t>
+              <a:t>2/3/2026</a:t>
             </a:fld>
             <a:endParaRPr lang="en-US" altLang="en-US"/>
           </a:p>
@@ -8053,6 +8053,10 @@
             </a:r>
           </a:p>
           <a:p>
+            <a:pPr>
+              <a:buFont typeface="Wingdings" panose="05000000000000000000" pitchFamily="2" charset="2"/>
+              <a:buChar char="q"/>
+            </a:pPr>
             <a:r>
               <a:rPr lang="en-US" sz="1800" dirty="0"/>
               <a:t>ContracthubPk successfully addresses </a:t>
@@ -8073,6 +8077,10 @@
             </a:r>
           </a:p>
           <a:p>
+            <a:pPr>
+              <a:buFont typeface="Wingdings" panose="05000000000000000000" pitchFamily="2" charset="2"/>
+              <a:buChar char="q"/>
+            </a:pPr>
             <a:r>
               <a:rPr lang="en-US" sz="1800" dirty="0"/>
               <a:t>Integration of </a:t>
@@ -8087,6 +8095,10 @@
             </a:r>
           </a:p>
           <a:p>
+            <a:pPr>
+              <a:buFont typeface="Wingdings" panose="05000000000000000000" pitchFamily="2" charset="2"/>
+              <a:buChar char="q"/>
+            </a:pPr>
             <a:r>
               <a:rPr lang="en-US" sz="1800" dirty="0"/>
               <a:t>Implementation of </a:t>
@@ -8101,6 +8113,10 @@
             </a:r>
           </a:p>
           <a:p>
+            <a:pPr>
+              <a:buFont typeface="Wingdings" panose="05000000000000000000" pitchFamily="2" charset="2"/>
+              <a:buChar char="q"/>
+            </a:pPr>
             <a:r>
               <a:rPr lang="en-US" sz="1800" dirty="0"/>
               <a:t>Support for </a:t>
@@ -8115,6 +8131,10 @@
             </a:r>
           </a:p>
           <a:p>
+            <a:pPr>
+              <a:buFont typeface="Wingdings" panose="05000000000000000000" pitchFamily="2" charset="2"/>
+              <a:buChar char="q"/>
+            </a:pPr>
             <a:r>
               <a:rPr lang="en-US" sz="1800" dirty="0"/>
               <a:t>Development of </a:t>
@@ -8228,7 +8248,7 @@
             <a:fld id="{616B4EEC-7D92-43E3-9DF5-5E76824E7D85}" type="datetime1">
               <a:rPr lang="en-US" altLang="en-US"/>
               <a:pPr/>
-              <a:t>1/10/2026</a:t>
+              <a:t>2/3/2026</a:t>
             </a:fld>
             <a:endParaRPr lang="en-US" altLang="en-US"/>
           </a:p>
@@ -8464,7 +8484,7 @@
             <a:fld id="{91813F7C-F4C7-4F8A-91E8-949324C2962E}" type="datetime1">
               <a:rPr lang="en-US" altLang="en-US"/>
               <a:pPr/>
-              <a:t>1/10/2026</a:t>
+              <a:t>2/3/2026</a:t>
             </a:fld>
             <a:endParaRPr lang="en-US" altLang="en-US"/>
           </a:p>
@@ -8672,7 +8692,7 @@
             <a:fld id="{BC24BE45-9672-4ECA-9AB2-C0AC69BFA8F6}" type="datetime1">
               <a:rPr lang="en-US" altLang="en-US"/>
               <a:pPr/>
-              <a:t>1/10/2026</a:t>
+              <a:t>2/3/2026</a:t>
             </a:fld>
             <a:endParaRPr lang="en-US" altLang="en-US"/>
           </a:p>
@@ -8749,7 +8769,7 @@
           <a:p>
             <a:r>
               <a:rPr lang="en-US" sz="2000" dirty="0"/>
-              <a:t>In Pakistan’s freelance market, most freelancers and clients rely on informal communication channels such as social media or messaging apps to negotiate and manage projects. This often leads to trust issues, payment fraud, lack of formal contracts, and project disputes. Existing international platforms like Fiverr and Upwork charge high commissions and do not support local payment gateways, making them less accessible for many users. Therefore, there is a need for a secure, automated web platform that allows freelancers and clients to create digital contracts, manage escrow based payments, and ensure transparent collaboration using local payment methods such as Easypaisa and JazzCash.</a:t>
+              <a:t>In Pakistan’s freelance market, most of the time freelancers and clients rely on informal communication channels such as social media or messaging apps like WhatsApp, Facebook and LinkedIn to negotiate and manage projects. This often leads to trust issues, payment scam, lack of formal contracts, and project disagreements. Existing international platforms like Fiverr and Upwork charge high charges and do not support local payment gateways, making them less accessible for many users. So, there is a need for a secure, automated web platform that allows freelancers and clients to make digital contracts, manage escrow payments, and confirm transparent association using local payment methods such as Easypaisa and JazzCash.</a:t>
             </a:r>
             <a:endParaRPr lang="en-PK" sz="2000" b="1" dirty="0"/>
           </a:p>
@@ -8838,7 +8858,7 @@
             <a:fld id="{4AC782DC-85FF-47EB-984B-4E94ACF0A85F}" type="datetime1">
               <a:rPr lang="en-US" altLang="en-US"/>
               <a:pPr/>
-              <a:t>1/10/2026</a:t>
+              <a:t>2/3/2026</a:t>
             </a:fld>
             <a:endParaRPr lang="en-US" altLang="en-US"/>
           </a:p>
@@ -9056,7 +9076,7 @@
             <a:fld id="{2061830D-EE20-4978-8216-ACEE0C233FC2}" type="datetime1">
               <a:rPr lang="en-US" altLang="en-US"/>
               <a:pPr/>
-              <a:t>1/10/2026</a:t>
+              <a:t>2/3/2026</a:t>
             </a:fld>
             <a:endParaRPr lang="en-US" altLang="en-US"/>
           </a:p>
@@ -9235,7 +9255,7 @@
             <a:fld id="{2061830D-EE20-4978-8216-ACEE0C233FC2}" type="datetime1">
               <a:rPr lang="en-US" altLang="en-US"/>
               <a:pPr/>
-              <a:t>1/10/2026</a:t>
+              <a:t>2/3/2026</a:t>
             </a:fld>
             <a:endParaRPr lang="en-US" altLang="en-US"/>
           </a:p>
@@ -9447,7 +9467,7 @@
             <a:fld id="{F85BF692-77CA-40CD-8285-FEAEA47698CF}" type="datetime1">
               <a:rPr lang="en-US" altLang="en-US"/>
               <a:pPr/>
-              <a:t>1/10/2026</a:t>
+              <a:t>2/3/2026</a:t>
             </a:fld>
             <a:endParaRPr lang="en-US" altLang="en-US"/>
           </a:p>
@@ -9728,7 +9748,7 @@
             <a:fld id="{3CFAEDAC-8F83-4A0E-9275-3AC03E30CD5E}" type="datetime1">
               <a:rPr lang="en-US" altLang="en-US"/>
               <a:pPr/>
-              <a:t>1/10/2026</a:t>
+              <a:t>2/3/2026</a:t>
             </a:fld>
             <a:endParaRPr lang="en-US" altLang="en-US"/>
           </a:p>
@@ -10045,7 +10065,7 @@
             <a:fld id="{F85BF692-77CA-40CD-8285-FEAEA47698CF}" type="datetime1">
               <a:rPr lang="en-US" altLang="en-US"/>
               <a:pPr/>
-              <a:t>1/10/2026</a:t>
+              <a:t>2/3/2026</a:t>
             </a:fld>
             <a:endParaRPr lang="en-US" altLang="en-US"/>
           </a:p>
@@ -10216,6 +10236,10 @@
             <a:endParaRPr lang="en-US" sz="1800" dirty="0"/>
           </a:p>
           <a:p>
+            <a:pPr>
+              <a:buFont typeface="Wingdings" panose="05000000000000000000" pitchFamily="2" charset="2"/>
+              <a:buChar char="q"/>
+            </a:pPr>
             <a:r>
               <a:rPr lang="en-US" sz="1800" dirty="0"/>
               <a:t>The </a:t>
@@ -10242,6 +10266,10 @@
             </a:r>
           </a:p>
           <a:p>
+            <a:pPr>
+              <a:buFont typeface="Wingdings" panose="05000000000000000000" pitchFamily="2" charset="2"/>
+              <a:buChar char="q"/>
+            </a:pPr>
             <a:r>
               <a:rPr lang="en-US" sz="1800" dirty="0"/>
               <a:t>The </a:t>
@@ -10264,6 +10292,10 @@
             </a:r>
           </a:p>
           <a:p>
+            <a:pPr>
+              <a:buFont typeface="Wingdings" panose="05000000000000000000" pitchFamily="2" charset="2"/>
+              <a:buChar char="q"/>
+            </a:pPr>
             <a:r>
               <a:rPr lang="en-US" sz="1800" dirty="0"/>
               <a:t>The </a:t>
@@ -10286,6 +10318,10 @@
             </a:r>
           </a:p>
           <a:p>
+            <a:pPr>
+              <a:buFont typeface="Wingdings" panose="05000000000000000000" pitchFamily="2" charset="2"/>
+              <a:buChar char="q"/>
+            </a:pPr>
             <a:r>
               <a:rPr lang="en-US" sz="1800" dirty="0"/>
               <a:t>For demonstration purposes, </a:t>

</xml_diff>